<commit_message>
Update pipeline run outputs and regenerated deck
- Populate outputs/log_model.txt from a full pipeline run
- Add outputs/log_ppt.txt with the figures sourced by the deck
- Regenerate f11_single_cycle_explanation.png and the SOH review deck

Co-Authored-By: Claude Opus 5 <noreply@anthropic.com>
</commit_message>
<xml_diff>
--- a/ML_Review1_EV_Battery_SOH_AD1.pptx
+++ b/ML_Review1_EV_Battery_SOH_AD1.pptx
@@ -3095,8 +3095,8 @@
         </p:blipFill>
         <p:spPr>
           <a:xfrm>
-            <a:off x="4782312" y="1218519"/>
-            <a:ext cx="3831335" cy="2098384"/>
+            <a:off x="4782312" y="1156412"/>
+            <a:ext cx="3831335" cy="2222598"/>
           </a:xfrm>
           <a:prstGeom prst="rect">
             <a:avLst/>
@@ -8802,8 +8802,8 @@
         </p:blipFill>
         <p:spPr>
           <a:xfrm>
-            <a:off x="530352" y="1170963"/>
-            <a:ext cx="4700016" cy="1736296"/>
+            <a:off x="530352" y="1170092"/>
+            <a:ext cx="4700016" cy="1738039"/>
           </a:xfrm>
           <a:prstGeom prst="rect">
             <a:avLst/>

</xml_diff>